<commit_message>
footer completed & ppt
</commit_message>
<xml_diff>
--- a/UrbanTime_FinalYearProject.pptx
+++ b/UrbanTime_FinalYearProject.pptx
@@ -5,20 +5,20 @@
     <p:sldMasterId id="2147483648" r:id="rId1"/>
   </p:sldMasterIdLst>
   <p:sldIdLst>
-    <p:sldId id="256" r:id="rId7"/>
-    <p:sldId id="257" r:id="rId8"/>
-    <p:sldId id="258" r:id="rId9"/>
-    <p:sldId id="259" r:id="rId10"/>
-    <p:sldId id="260" r:id="rId11"/>
-    <p:sldId id="261" r:id="rId12"/>
-    <p:sldId id="262" r:id="rId13"/>
-    <p:sldId id="263" r:id="rId14"/>
-    <p:sldId id="264" r:id="rId15"/>
-    <p:sldId id="265" r:id="rId16"/>
-    <p:sldId id="266" r:id="rId17"/>
-    <p:sldId id="267" r:id="rId18"/>
+    <p:sldId id="256" r:id="rId2"/>
+    <p:sldId id="257" r:id="rId3"/>
+    <p:sldId id="258" r:id="rId4"/>
+    <p:sldId id="259" r:id="rId5"/>
+    <p:sldId id="260" r:id="rId6"/>
+    <p:sldId id="261" r:id="rId7"/>
+    <p:sldId id="262" r:id="rId8"/>
+    <p:sldId id="263" r:id="rId9"/>
+    <p:sldId id="264" r:id="rId10"/>
+    <p:sldId id="265" r:id="rId11"/>
+    <p:sldId id="266" r:id="rId12"/>
+    <p:sldId id="267" r:id="rId13"/>
   </p:sldIdLst>
-  <p:sldSz cx="12191695" cy="6858000" type="screen4x3"/>
+  <p:sldSz cx="12192000" cy="6858000"/>
   <p:notesSz cx="6858000" cy="9144000"/>
   <p:defaultTextStyle>
     <a:defPPr>
@@ -115,6 +115,22 @@
       </a:defRPr>
     </a:lvl9pPr>
   </p:defaultTextStyle>
+  <p:extLst>
+    <p:ext uri="{EFAFB233-063F-42B5-8137-9DF3F51BA10A}">
+      <p15:sldGuideLst xmlns:p15="http://schemas.microsoft.com/office/powerpoint/2012/main">
+        <p15:guide id="1" orient="horz" pos="2160">
+          <p15:clr>
+            <a:srgbClr val="A4A3A4"/>
+          </p15:clr>
+        </p15:guide>
+        <p15:guide id="2" pos="2880">
+          <p15:clr>
+            <a:srgbClr val="A4A3A4"/>
+          </p15:clr>
+        </p15:guide>
+      </p15:sldGuideLst>
+    </p:ext>
+  </p:extLst>
 </p:presentation>
 </file>
 
@@ -156,10 +172,9 @@
           <a:lstStyle/>
           <a:p>
             <a:r>
-              <a:rPr lang="en-US" smtClean="0"/>
+              <a:rPr lang="en-US"/>
               <a:t>Click to edit Master title style</a:t>
             </a:r>
-            <a:endParaRPr lang="en-US"/>
           </a:p>
         </p:txBody>
       </p:sp>
@@ -275,10 +290,9 @@
           </a:lstStyle>
           <a:p>
             <a:r>
-              <a:rPr lang="en-US" smtClean="0"/>
+              <a:rPr lang="en-US"/>
               <a:t>Click to edit Master subtitle style</a:t>
             </a:r>
-            <a:endParaRPr lang="en-US"/>
           </a:p>
         </p:txBody>
       </p:sp>
@@ -299,7 +313,7 @@
           <a:p>
             <a:fld id="{5BCAD085-E8A6-8845-BD4E-CB4CCA059FC4}" type="datetimeFigureOut">
               <a:rPr lang="en-US" smtClean="0"/>
-              <a:t>1/27/13</a:t>
+              <a:t>3/27/2026</a:t>
             </a:fld>
             <a:endParaRPr lang="en-US"/>
           </a:p>
@@ -393,10 +407,9 @@
           <a:lstStyle/>
           <a:p>
             <a:r>
-              <a:rPr lang="en-US" smtClean="0"/>
+              <a:rPr lang="en-US"/>
               <a:t>Click to edit Master title style</a:t>
             </a:r>
-            <a:endParaRPr lang="en-US"/>
           </a:p>
         </p:txBody>
       </p:sp>
@@ -417,38 +430,37 @@
           <a:p>
             <a:pPr lvl="0"/>
             <a:r>
-              <a:rPr lang="en-US" smtClean="0"/>
+              <a:rPr lang="en-US"/>
               <a:t>Click to edit Master text styles</a:t>
             </a:r>
           </a:p>
           <a:p>
             <a:pPr lvl="1"/>
             <a:r>
-              <a:rPr lang="en-US" smtClean="0"/>
+              <a:rPr lang="en-US"/>
               <a:t>Second level</a:t>
             </a:r>
           </a:p>
           <a:p>
             <a:pPr lvl="2"/>
             <a:r>
-              <a:rPr lang="en-US" smtClean="0"/>
+              <a:rPr lang="en-US"/>
               <a:t>Third level</a:t>
             </a:r>
           </a:p>
           <a:p>
             <a:pPr lvl="3"/>
             <a:r>
-              <a:rPr lang="en-US" smtClean="0"/>
+              <a:rPr lang="en-US"/>
               <a:t>Fourth level</a:t>
             </a:r>
           </a:p>
           <a:p>
             <a:pPr lvl="4"/>
             <a:r>
-              <a:rPr lang="en-US" smtClean="0"/>
+              <a:rPr lang="en-US"/>
               <a:t>Fifth level</a:t>
             </a:r>
-            <a:endParaRPr lang="en-US"/>
           </a:p>
         </p:txBody>
       </p:sp>
@@ -469,7 +481,7 @@
           <a:p>
             <a:fld id="{5BCAD085-E8A6-8845-BD4E-CB4CCA059FC4}" type="datetimeFigureOut">
               <a:rPr lang="en-US" smtClean="0"/>
-              <a:t>1/27/13</a:t>
+              <a:t>3/27/2026</a:t>
             </a:fld>
             <a:endParaRPr lang="en-US"/>
           </a:p>
@@ -568,10 +580,9 @@
           <a:lstStyle/>
           <a:p>
             <a:r>
-              <a:rPr lang="en-US" smtClean="0"/>
+              <a:rPr lang="en-US"/>
               <a:t>Click to edit Master title style</a:t>
             </a:r>
-            <a:endParaRPr lang="en-US"/>
           </a:p>
         </p:txBody>
       </p:sp>
@@ -597,38 +608,37 @@
           <a:p>
             <a:pPr lvl="0"/>
             <a:r>
-              <a:rPr lang="en-US" smtClean="0"/>
+              <a:rPr lang="en-US"/>
               <a:t>Click to edit Master text styles</a:t>
             </a:r>
           </a:p>
           <a:p>
             <a:pPr lvl="1"/>
             <a:r>
-              <a:rPr lang="en-US" smtClean="0"/>
+              <a:rPr lang="en-US"/>
               <a:t>Second level</a:t>
             </a:r>
           </a:p>
           <a:p>
             <a:pPr lvl="2"/>
             <a:r>
-              <a:rPr lang="en-US" smtClean="0"/>
+              <a:rPr lang="en-US"/>
               <a:t>Third level</a:t>
             </a:r>
           </a:p>
           <a:p>
             <a:pPr lvl="3"/>
             <a:r>
-              <a:rPr lang="en-US" smtClean="0"/>
+              <a:rPr lang="en-US"/>
               <a:t>Fourth level</a:t>
             </a:r>
           </a:p>
           <a:p>
             <a:pPr lvl="4"/>
             <a:r>
-              <a:rPr lang="en-US" smtClean="0"/>
+              <a:rPr lang="en-US"/>
               <a:t>Fifth level</a:t>
             </a:r>
-            <a:endParaRPr lang="en-US"/>
           </a:p>
         </p:txBody>
       </p:sp>
@@ -649,7 +659,7 @@
           <a:p>
             <a:fld id="{5BCAD085-E8A6-8845-BD4E-CB4CCA059FC4}" type="datetimeFigureOut">
               <a:rPr lang="en-US" smtClean="0"/>
-              <a:t>1/27/13</a:t>
+              <a:t>3/27/2026</a:t>
             </a:fld>
             <a:endParaRPr lang="en-US"/>
           </a:p>
@@ -743,10 +753,9 @@
           <a:lstStyle/>
           <a:p>
             <a:r>
-              <a:rPr lang="en-US" smtClean="0"/>
+              <a:rPr lang="en-US"/>
               <a:t>Click to edit Master title style</a:t>
             </a:r>
-            <a:endParaRPr lang="en-US"/>
           </a:p>
         </p:txBody>
       </p:sp>
@@ -767,38 +776,37 @@
           <a:p>
             <a:pPr lvl="0"/>
             <a:r>
-              <a:rPr lang="en-US" smtClean="0"/>
+              <a:rPr lang="en-US"/>
               <a:t>Click to edit Master text styles</a:t>
             </a:r>
           </a:p>
           <a:p>
             <a:pPr lvl="1"/>
             <a:r>
-              <a:rPr lang="en-US" smtClean="0"/>
+              <a:rPr lang="en-US"/>
               <a:t>Second level</a:t>
             </a:r>
           </a:p>
           <a:p>
             <a:pPr lvl="2"/>
             <a:r>
-              <a:rPr lang="en-US" smtClean="0"/>
+              <a:rPr lang="en-US"/>
               <a:t>Third level</a:t>
             </a:r>
           </a:p>
           <a:p>
             <a:pPr lvl="3"/>
             <a:r>
-              <a:rPr lang="en-US" smtClean="0"/>
+              <a:rPr lang="en-US"/>
               <a:t>Fourth level</a:t>
             </a:r>
           </a:p>
           <a:p>
             <a:pPr lvl="4"/>
             <a:r>
-              <a:rPr lang="en-US" smtClean="0"/>
+              <a:rPr lang="en-US"/>
               <a:t>Fifth level</a:t>
             </a:r>
-            <a:endParaRPr lang="en-US"/>
           </a:p>
         </p:txBody>
       </p:sp>
@@ -819,7 +827,7 @@
           <a:p>
             <a:fld id="{5BCAD085-E8A6-8845-BD4E-CB4CCA059FC4}" type="datetimeFigureOut">
               <a:rPr lang="en-US" smtClean="0"/>
-              <a:t>1/27/13</a:t>
+              <a:t>3/27/2026</a:t>
             </a:fld>
             <a:endParaRPr lang="en-US"/>
           </a:p>
@@ -922,10 +930,9 @@
           </a:lstStyle>
           <a:p>
             <a:r>
-              <a:rPr lang="en-US" smtClean="0"/>
+              <a:rPr lang="en-US"/>
               <a:t>Click to edit Master title style</a:t>
             </a:r>
-            <a:endParaRPr lang="en-US"/>
           </a:p>
         </p:txBody>
       </p:sp>
@@ -1042,7 +1049,7 @@
           <a:p>
             <a:pPr lvl="0"/>
             <a:r>
-              <a:rPr lang="en-US" smtClean="0"/>
+              <a:rPr lang="en-US"/>
               <a:t>Click to edit Master text styles</a:t>
             </a:r>
           </a:p>
@@ -1065,7 +1072,7 @@
           <a:p>
             <a:fld id="{5BCAD085-E8A6-8845-BD4E-CB4CCA059FC4}" type="datetimeFigureOut">
               <a:rPr lang="en-US" smtClean="0"/>
-              <a:t>1/27/13</a:t>
+              <a:t>3/27/2026</a:t>
             </a:fld>
             <a:endParaRPr lang="en-US"/>
           </a:p>
@@ -1159,10 +1166,9 @@
           <a:lstStyle/>
           <a:p>
             <a:r>
-              <a:rPr lang="en-US" smtClean="0"/>
+              <a:rPr lang="en-US"/>
               <a:t>Click to edit Master title style</a:t>
             </a:r>
-            <a:endParaRPr lang="en-US"/>
           </a:p>
         </p:txBody>
       </p:sp>
@@ -1216,38 +1222,37 @@
           <a:p>
             <a:pPr lvl="0"/>
             <a:r>
-              <a:rPr lang="en-US" smtClean="0"/>
+              <a:rPr lang="en-US"/>
               <a:t>Click to edit Master text styles</a:t>
             </a:r>
           </a:p>
           <a:p>
             <a:pPr lvl="1"/>
             <a:r>
-              <a:rPr lang="en-US" smtClean="0"/>
+              <a:rPr lang="en-US"/>
               <a:t>Second level</a:t>
             </a:r>
           </a:p>
           <a:p>
             <a:pPr lvl="2"/>
             <a:r>
-              <a:rPr lang="en-US" smtClean="0"/>
+              <a:rPr lang="en-US"/>
               <a:t>Third level</a:t>
             </a:r>
           </a:p>
           <a:p>
             <a:pPr lvl="3"/>
             <a:r>
-              <a:rPr lang="en-US" smtClean="0"/>
+              <a:rPr lang="en-US"/>
               <a:t>Fourth level</a:t>
             </a:r>
           </a:p>
           <a:p>
             <a:pPr lvl="4"/>
             <a:r>
-              <a:rPr lang="en-US" smtClean="0"/>
+              <a:rPr lang="en-US"/>
               <a:t>Fifth level</a:t>
             </a:r>
-            <a:endParaRPr lang="en-US"/>
           </a:p>
         </p:txBody>
       </p:sp>
@@ -1301,38 +1306,37 @@
           <a:p>
             <a:pPr lvl="0"/>
             <a:r>
-              <a:rPr lang="en-US" smtClean="0"/>
+              <a:rPr lang="en-US"/>
               <a:t>Click to edit Master text styles</a:t>
             </a:r>
           </a:p>
           <a:p>
             <a:pPr lvl="1"/>
             <a:r>
-              <a:rPr lang="en-US" smtClean="0"/>
+              <a:rPr lang="en-US"/>
               <a:t>Second level</a:t>
             </a:r>
           </a:p>
           <a:p>
             <a:pPr lvl="2"/>
             <a:r>
-              <a:rPr lang="en-US" smtClean="0"/>
+              <a:rPr lang="en-US"/>
               <a:t>Third level</a:t>
             </a:r>
           </a:p>
           <a:p>
             <a:pPr lvl="3"/>
             <a:r>
-              <a:rPr lang="en-US" smtClean="0"/>
+              <a:rPr lang="en-US"/>
               <a:t>Fourth level</a:t>
             </a:r>
           </a:p>
           <a:p>
             <a:pPr lvl="4"/>
             <a:r>
-              <a:rPr lang="en-US" smtClean="0"/>
+              <a:rPr lang="en-US"/>
               <a:t>Fifth level</a:t>
             </a:r>
-            <a:endParaRPr lang="en-US"/>
           </a:p>
         </p:txBody>
       </p:sp>
@@ -1353,7 +1357,7 @@
           <a:p>
             <a:fld id="{5BCAD085-E8A6-8845-BD4E-CB4CCA059FC4}" type="datetimeFigureOut">
               <a:rPr lang="en-US" smtClean="0"/>
-              <a:t>1/27/13</a:t>
+              <a:t>3/27/2026</a:t>
             </a:fld>
             <a:endParaRPr lang="en-US"/>
           </a:p>
@@ -1451,10 +1455,9 @@
           </a:lstStyle>
           <a:p>
             <a:r>
-              <a:rPr lang="en-US" smtClean="0"/>
+              <a:rPr lang="en-US"/>
               <a:t>Click to edit Master title style</a:t>
             </a:r>
-            <a:endParaRPr lang="en-US"/>
           </a:p>
         </p:txBody>
       </p:sp>
@@ -1517,7 +1520,7 @@
           <a:p>
             <a:pPr lvl="0"/>
             <a:r>
-              <a:rPr lang="en-US" smtClean="0"/>
+              <a:rPr lang="en-US"/>
               <a:t>Click to edit Master text styles</a:t>
             </a:r>
           </a:p>
@@ -1573,38 +1576,37 @@
           <a:p>
             <a:pPr lvl="0"/>
             <a:r>
-              <a:rPr lang="en-US" smtClean="0"/>
+              <a:rPr lang="en-US"/>
               <a:t>Click to edit Master text styles</a:t>
             </a:r>
           </a:p>
           <a:p>
             <a:pPr lvl="1"/>
             <a:r>
-              <a:rPr lang="en-US" smtClean="0"/>
+              <a:rPr lang="en-US"/>
               <a:t>Second level</a:t>
             </a:r>
           </a:p>
           <a:p>
             <a:pPr lvl="2"/>
             <a:r>
-              <a:rPr lang="en-US" smtClean="0"/>
+              <a:rPr lang="en-US"/>
               <a:t>Third level</a:t>
             </a:r>
           </a:p>
           <a:p>
             <a:pPr lvl="3"/>
             <a:r>
-              <a:rPr lang="en-US" smtClean="0"/>
+              <a:rPr lang="en-US"/>
               <a:t>Fourth level</a:t>
             </a:r>
           </a:p>
           <a:p>
             <a:pPr lvl="4"/>
             <a:r>
-              <a:rPr lang="en-US" smtClean="0"/>
+              <a:rPr lang="en-US"/>
               <a:t>Fifth level</a:t>
             </a:r>
-            <a:endParaRPr lang="en-US"/>
           </a:p>
         </p:txBody>
       </p:sp>
@@ -1667,7 +1669,7 @@
           <a:p>
             <a:pPr lvl="0"/>
             <a:r>
-              <a:rPr lang="en-US" smtClean="0"/>
+              <a:rPr lang="en-US"/>
               <a:t>Click to edit Master text styles</a:t>
             </a:r>
           </a:p>
@@ -1723,38 +1725,37 @@
           <a:p>
             <a:pPr lvl="0"/>
             <a:r>
-              <a:rPr lang="en-US" smtClean="0"/>
+              <a:rPr lang="en-US"/>
               <a:t>Click to edit Master text styles</a:t>
             </a:r>
           </a:p>
           <a:p>
             <a:pPr lvl="1"/>
             <a:r>
-              <a:rPr lang="en-US" smtClean="0"/>
+              <a:rPr lang="en-US"/>
               <a:t>Second level</a:t>
             </a:r>
           </a:p>
           <a:p>
             <a:pPr lvl="2"/>
             <a:r>
-              <a:rPr lang="en-US" smtClean="0"/>
+              <a:rPr lang="en-US"/>
               <a:t>Third level</a:t>
             </a:r>
           </a:p>
           <a:p>
             <a:pPr lvl="3"/>
             <a:r>
-              <a:rPr lang="en-US" smtClean="0"/>
+              <a:rPr lang="en-US"/>
               <a:t>Fourth level</a:t>
             </a:r>
           </a:p>
           <a:p>
             <a:pPr lvl="4"/>
             <a:r>
-              <a:rPr lang="en-US" smtClean="0"/>
+              <a:rPr lang="en-US"/>
               <a:t>Fifth level</a:t>
             </a:r>
-            <a:endParaRPr lang="en-US"/>
           </a:p>
         </p:txBody>
       </p:sp>
@@ -1775,7 +1776,7 @@
           <a:p>
             <a:fld id="{5BCAD085-E8A6-8845-BD4E-CB4CCA059FC4}" type="datetimeFigureOut">
               <a:rPr lang="en-US" smtClean="0"/>
-              <a:t>1/27/13</a:t>
+              <a:t>3/27/2026</a:t>
             </a:fld>
             <a:endParaRPr lang="en-US"/>
           </a:p>
@@ -1869,10 +1870,9 @@
           <a:lstStyle/>
           <a:p>
             <a:r>
-              <a:rPr lang="en-US" smtClean="0"/>
+              <a:rPr lang="en-US"/>
               <a:t>Click to edit Master title style</a:t>
             </a:r>
-            <a:endParaRPr lang="en-US"/>
           </a:p>
         </p:txBody>
       </p:sp>
@@ -1893,7 +1893,7 @@
           <a:p>
             <a:fld id="{5BCAD085-E8A6-8845-BD4E-CB4CCA059FC4}" type="datetimeFigureOut">
               <a:rPr lang="en-US" smtClean="0"/>
-              <a:t>1/27/13</a:t>
+              <a:t>3/27/2026</a:t>
             </a:fld>
             <a:endParaRPr lang="en-US"/>
           </a:p>
@@ -1988,7 +1988,7 @@
           <a:p>
             <a:fld id="{5BCAD085-E8A6-8845-BD4E-CB4CCA059FC4}" type="datetimeFigureOut">
               <a:rPr lang="en-US" smtClean="0"/>
-              <a:t>1/27/13</a:t>
+              <a:t>3/27/2026</a:t>
             </a:fld>
             <a:endParaRPr lang="en-US"/>
           </a:p>
@@ -2091,10 +2091,9 @@
           </a:lstStyle>
           <a:p>
             <a:r>
-              <a:rPr lang="en-US" smtClean="0"/>
+              <a:rPr lang="en-US"/>
               <a:t>Click to edit Master title style</a:t>
             </a:r>
-            <a:endParaRPr lang="en-US"/>
           </a:p>
         </p:txBody>
       </p:sp>
@@ -2148,38 +2147,37 @@
           <a:p>
             <a:pPr lvl="0"/>
             <a:r>
-              <a:rPr lang="en-US" smtClean="0"/>
+              <a:rPr lang="en-US"/>
               <a:t>Click to edit Master text styles</a:t>
             </a:r>
           </a:p>
           <a:p>
             <a:pPr lvl="1"/>
             <a:r>
-              <a:rPr lang="en-US" smtClean="0"/>
+              <a:rPr lang="en-US"/>
               <a:t>Second level</a:t>
             </a:r>
           </a:p>
           <a:p>
             <a:pPr lvl="2"/>
             <a:r>
-              <a:rPr lang="en-US" smtClean="0"/>
+              <a:rPr lang="en-US"/>
               <a:t>Third level</a:t>
             </a:r>
           </a:p>
           <a:p>
             <a:pPr lvl="3"/>
             <a:r>
-              <a:rPr lang="en-US" smtClean="0"/>
+              <a:rPr lang="en-US"/>
               <a:t>Fourth level</a:t>
             </a:r>
           </a:p>
           <a:p>
             <a:pPr lvl="4"/>
             <a:r>
-              <a:rPr lang="en-US" smtClean="0"/>
+              <a:rPr lang="en-US"/>
               <a:t>Fifth level</a:t>
             </a:r>
-            <a:endParaRPr lang="en-US"/>
           </a:p>
         </p:txBody>
       </p:sp>
@@ -2242,7 +2240,7 @@
           <a:p>
             <a:pPr lvl="0"/>
             <a:r>
-              <a:rPr lang="en-US" smtClean="0"/>
+              <a:rPr lang="en-US"/>
               <a:t>Click to edit Master text styles</a:t>
             </a:r>
           </a:p>
@@ -2265,7 +2263,7 @@
           <a:p>
             <a:fld id="{5BCAD085-E8A6-8845-BD4E-CB4CCA059FC4}" type="datetimeFigureOut">
               <a:rPr lang="en-US" smtClean="0"/>
-              <a:t>1/27/13</a:t>
+              <a:t>3/27/2026</a:t>
             </a:fld>
             <a:endParaRPr lang="en-US"/>
           </a:p>
@@ -2368,10 +2366,9 @@
           </a:lstStyle>
           <a:p>
             <a:r>
-              <a:rPr lang="en-US" smtClean="0"/>
+              <a:rPr lang="en-US"/>
               <a:t>Click to edit Master title style</a:t>
             </a:r>
-            <a:endParaRPr lang="en-US"/>
           </a:p>
         </p:txBody>
       </p:sp>
@@ -2495,7 +2492,7 @@
           <a:p>
             <a:pPr lvl="0"/>
             <a:r>
-              <a:rPr lang="en-US" smtClean="0"/>
+              <a:rPr lang="en-US"/>
               <a:t>Click to edit Master text styles</a:t>
             </a:r>
           </a:p>
@@ -2518,7 +2515,7 @@
           <a:p>
             <a:fld id="{5BCAD085-E8A6-8845-BD4E-CB4CCA059FC4}" type="datetimeFigureOut">
               <a:rPr lang="en-US" smtClean="0"/>
-              <a:t>1/27/13</a:t>
+              <a:t>3/27/2026</a:t>
             </a:fld>
             <a:endParaRPr lang="en-US"/>
           </a:p>
@@ -2627,10 +2624,9 @@
           <a:lstStyle/>
           <a:p>
             <a:r>
-              <a:rPr lang="en-US" smtClean="0"/>
+              <a:rPr lang="en-US"/>
               <a:t>Click to edit Master title style</a:t>
             </a:r>
-            <a:endParaRPr lang="en-US"/>
           </a:p>
         </p:txBody>
       </p:sp>
@@ -2661,38 +2657,37 @@
           <a:p>
             <a:pPr lvl="0"/>
             <a:r>
-              <a:rPr lang="en-US" smtClean="0"/>
+              <a:rPr lang="en-US"/>
               <a:t>Click to edit Master text styles</a:t>
             </a:r>
           </a:p>
           <a:p>
             <a:pPr lvl="1"/>
             <a:r>
-              <a:rPr lang="en-US" smtClean="0"/>
+              <a:rPr lang="en-US"/>
               <a:t>Second level</a:t>
             </a:r>
           </a:p>
           <a:p>
             <a:pPr lvl="2"/>
             <a:r>
-              <a:rPr lang="en-US" smtClean="0"/>
+              <a:rPr lang="en-US"/>
               <a:t>Third level</a:t>
             </a:r>
           </a:p>
           <a:p>
             <a:pPr lvl="3"/>
             <a:r>
-              <a:rPr lang="en-US" smtClean="0"/>
+              <a:rPr lang="en-US"/>
               <a:t>Fourth level</a:t>
             </a:r>
           </a:p>
           <a:p>
             <a:pPr lvl="4"/>
             <a:r>
-              <a:rPr lang="en-US" smtClean="0"/>
+              <a:rPr lang="en-US"/>
               <a:t>Fifth level</a:t>
             </a:r>
-            <a:endParaRPr lang="en-US"/>
           </a:p>
         </p:txBody>
       </p:sp>
@@ -2731,7 +2726,7 @@
           <a:p>
             <a:fld id="{5BCAD085-E8A6-8845-BD4E-CB4CCA059FC4}" type="datetimeFigureOut">
               <a:rPr lang="en-US" smtClean="0"/>
-              <a:t>1/27/13</a:t>
+              <a:t>3/27/2026</a:t>
             </a:fld>
             <a:endParaRPr lang="en-US"/>
           </a:p>
@@ -3090,7 +3085,7 @@
 </file>
 
 <file path=ppt/slides/slide1.xml><?xml version="1.0" encoding="utf-8"?>
-<p:sld xmlns:a="http://schemas.openxmlformats.org/drawingml/2006/main" xmlns:p="http://schemas.openxmlformats.org/presentationml/2006/main" xmlns:r="http://schemas.openxmlformats.org/officeDocument/2006/relationships">
+<p:sld xmlns:a="http://schemas.openxmlformats.org/drawingml/2006/main" xmlns:r="http://schemas.openxmlformats.org/officeDocument/2006/relationships" xmlns:p="http://schemas.openxmlformats.org/presentationml/2006/main">
   <p:cSld>
     <p:bg>
       <p:bgPr>
@@ -3106,7 +3101,14 @@
         <p:cNvGrpSpPr/>
         <p:nvPr/>
       </p:nvGrpSpPr>
-      <p:grpSpPr/>
+      <p:grpSpPr>
+        <a:xfrm>
+          <a:off x="0" y="0"/>
+          <a:ext cx="0" cy="0"/>
+          <a:chOff x="0" y="0"/>
+          <a:chExt cx="0" cy="0"/>
+        </a:xfrm>
+      </p:grpSpPr>
       <p:sp>
         <p:nvSpPr>
           <p:cNvPr id="2" name="Rectangle 1"/>
@@ -3147,6 +3149,7 @@
           <a:lstStyle/>
           <a:p>
             <a:pPr algn="ctr"/>
+            <a:endParaRPr/>
           </a:p>
         </p:txBody>
       </p:sp>
@@ -3225,6 +3228,7 @@
           <a:lstStyle/>
           <a:p>
             <a:pPr algn="ctr"/>
+            <a:endParaRPr/>
           </a:p>
         </p:txBody>
       </p:sp>
@@ -3338,6 +3342,7 @@
           <a:lstStyle/>
           <a:p>
             <a:pPr algn="ctr"/>
+            <a:endParaRPr/>
           </a:p>
         </p:txBody>
       </p:sp>
@@ -3451,6 +3456,7 @@
           <a:lstStyle/>
           <a:p>
             <a:pPr algn="ctr"/>
+            <a:endParaRPr/>
           </a:p>
         </p:txBody>
       </p:sp>
@@ -3498,7 +3504,7 @@
         <p:spPr>
           <a:xfrm>
             <a:off x="5029200" y="5029200"/>
-            <a:ext cx="2286000" cy="548640"/>
+            <a:ext cx="2286000" cy="323165"/>
           </a:xfrm>
           <a:prstGeom prst="rect">
             <a:avLst/>
@@ -3519,8 +3525,14 @@
               </a:defRPr>
             </a:pPr>
             <a:r>
+              <a:rPr dirty="0"/>
               <a:t>E-Commerce</a:t>
             </a:r>
+            <a:r>
+              <a:rPr lang="en-US" dirty="0"/>
+              <a:t> Website</a:t>
+            </a:r>
+            <a:endParaRPr dirty="0"/>
           </a:p>
         </p:txBody>
       </p:sp>
@@ -3564,6 +3576,7 @@
           <a:lstStyle/>
           <a:p>
             <a:pPr algn="ctr"/>
+            <a:endParaRPr/>
           </a:p>
         </p:txBody>
       </p:sp>
@@ -3611,7 +3624,7 @@
         <p:spPr>
           <a:xfrm>
             <a:off x="7772400" y="5029200"/>
-            <a:ext cx="2286000" cy="548640"/>
+            <a:ext cx="2286000" cy="323165"/>
           </a:xfrm>
           <a:prstGeom prst="rect">
             <a:avLst/>
@@ -3632,8 +3645,10 @@
               </a:defRPr>
             </a:pPr>
             <a:r>
-              <a:t>Final Year Project</a:t>
-            </a:r>
+              <a:rPr lang="en-US" dirty="0"/>
+              <a:t>Mayank Singh</a:t>
+            </a:r>
+            <a:endParaRPr dirty="0"/>
           </a:p>
         </p:txBody>
       </p:sp>
@@ -3681,7 +3696,7 @@
 </file>
 
 <file path=ppt/slides/slide10.xml><?xml version="1.0" encoding="utf-8"?>
-<p:sld xmlns:a="http://schemas.openxmlformats.org/drawingml/2006/main" xmlns:p="http://schemas.openxmlformats.org/presentationml/2006/main" xmlns:r="http://schemas.openxmlformats.org/officeDocument/2006/relationships">
+<p:sld xmlns:a="http://schemas.openxmlformats.org/drawingml/2006/main" xmlns:r="http://schemas.openxmlformats.org/officeDocument/2006/relationships" xmlns:p="http://schemas.openxmlformats.org/presentationml/2006/main">
   <p:cSld>
     <p:bg>
       <p:bgPr>
@@ -3697,7 +3712,14 @@
         <p:cNvGrpSpPr/>
         <p:nvPr/>
       </p:nvGrpSpPr>
-      <p:grpSpPr/>
+      <p:grpSpPr>
+        <a:xfrm>
+          <a:off x="0" y="0"/>
+          <a:ext cx="0" cy="0"/>
+          <a:chOff x="0" y="0"/>
+          <a:chExt cx="0" cy="0"/>
+        </a:xfrm>
+      </p:grpSpPr>
       <p:sp>
         <p:nvSpPr>
           <p:cNvPr id="2" name="Rectangle 1"/>
@@ -3738,6 +3760,7 @@
           <a:lstStyle/>
           <a:p>
             <a:pPr algn="ctr"/>
+            <a:endParaRPr/>
           </a:p>
         </p:txBody>
       </p:sp>
@@ -3816,6 +3839,7 @@
           <a:lstStyle/>
           <a:p>
             <a:pPr algn="ctr"/>
+            <a:endParaRPr/>
           </a:p>
         </p:txBody>
       </p:sp>
@@ -3859,6 +3883,7 @@
           <a:lstStyle/>
           <a:p>
             <a:pPr algn="ctr"/>
+            <a:endParaRPr/>
           </a:p>
         </p:txBody>
       </p:sp>
@@ -4007,6 +4032,7 @@
           <a:lstStyle/>
           <a:p>
             <a:pPr algn="ctr"/>
+            <a:endParaRPr/>
           </a:p>
         </p:txBody>
       </p:sp>
@@ -4155,6 +4181,7 @@
           <a:lstStyle/>
           <a:p>
             <a:pPr algn="ctr"/>
+            <a:endParaRPr/>
           </a:p>
         </p:txBody>
       </p:sp>
@@ -4303,6 +4330,7 @@
           <a:lstStyle/>
           <a:p>
             <a:pPr algn="ctr"/>
+            <a:endParaRPr/>
           </a:p>
         </p:txBody>
       </p:sp>
@@ -4451,6 +4479,7 @@
           <a:lstStyle/>
           <a:p>
             <a:pPr algn="ctr"/>
+            <a:endParaRPr/>
           </a:p>
         </p:txBody>
       </p:sp>
@@ -4599,6 +4628,7 @@
           <a:lstStyle/>
           <a:p>
             <a:pPr algn="ctr"/>
+            <a:endParaRPr/>
           </a:p>
         </p:txBody>
       </p:sp>
@@ -4747,6 +4777,7 @@
           <a:lstStyle/>
           <a:p>
             <a:pPr algn="ctr"/>
+            <a:endParaRPr/>
           </a:p>
         </p:txBody>
       </p:sp>
@@ -4895,6 +4926,7 @@
           <a:lstStyle/>
           <a:p>
             <a:pPr algn="ctr"/>
+            <a:endParaRPr/>
           </a:p>
         </p:txBody>
       </p:sp>
@@ -5047,7 +5079,7 @@
 </file>
 
 <file path=ppt/slides/slide11.xml><?xml version="1.0" encoding="utf-8"?>
-<p:sld xmlns:a="http://schemas.openxmlformats.org/drawingml/2006/main" xmlns:p="http://schemas.openxmlformats.org/presentationml/2006/main" xmlns:r="http://schemas.openxmlformats.org/officeDocument/2006/relationships">
+<p:sld xmlns:a="http://schemas.openxmlformats.org/drawingml/2006/main" xmlns:r="http://schemas.openxmlformats.org/officeDocument/2006/relationships" xmlns:p="http://schemas.openxmlformats.org/presentationml/2006/main">
   <p:cSld>
     <p:bg>
       <p:bgPr>
@@ -5063,7 +5095,14 @@
         <p:cNvGrpSpPr/>
         <p:nvPr/>
       </p:nvGrpSpPr>
-      <p:grpSpPr/>
+      <p:grpSpPr>
+        <a:xfrm>
+          <a:off x="0" y="0"/>
+          <a:ext cx="0" cy="0"/>
+          <a:chOff x="0" y="0"/>
+          <a:chExt cx="0" cy="0"/>
+        </a:xfrm>
+      </p:grpSpPr>
       <p:sp>
         <p:nvSpPr>
           <p:cNvPr id="2" name="Rectangle 1"/>
@@ -5104,6 +5143,7 @@
           <a:lstStyle/>
           <a:p>
             <a:pPr algn="ctr"/>
+            <a:endParaRPr/>
           </a:p>
         </p:txBody>
       </p:sp>
@@ -5182,6 +5222,7 @@
           <a:lstStyle/>
           <a:p>
             <a:pPr algn="ctr"/>
+            <a:endParaRPr/>
           </a:p>
         </p:txBody>
       </p:sp>
@@ -5260,6 +5301,7 @@
           <a:lstStyle/>
           <a:p>
             <a:pPr algn="ctr"/>
+            <a:endParaRPr/>
           </a:p>
         </p:txBody>
       </p:sp>
@@ -5408,6 +5450,7 @@
           <a:lstStyle/>
           <a:p>
             <a:pPr algn="ctr"/>
+            <a:endParaRPr/>
           </a:p>
         </p:txBody>
       </p:sp>
@@ -5556,6 +5599,7 @@
           <a:lstStyle/>
           <a:p>
             <a:pPr algn="ctr"/>
+            <a:endParaRPr/>
           </a:p>
         </p:txBody>
       </p:sp>
@@ -5704,6 +5748,7 @@
           <a:lstStyle/>
           <a:p>
             <a:pPr algn="ctr"/>
+            <a:endParaRPr/>
           </a:p>
         </p:txBody>
       </p:sp>
@@ -5852,6 +5897,7 @@
           <a:lstStyle/>
           <a:p>
             <a:pPr algn="ctr"/>
+            <a:endParaRPr/>
           </a:p>
         </p:txBody>
       </p:sp>
@@ -6000,6 +6046,7 @@
           <a:lstStyle/>
           <a:p>
             <a:pPr algn="ctr"/>
+            <a:endParaRPr/>
           </a:p>
         </p:txBody>
       </p:sp>
@@ -6148,6 +6195,7 @@
           <a:lstStyle/>
           <a:p>
             <a:pPr algn="ctr"/>
+            <a:endParaRPr/>
           </a:p>
         </p:txBody>
       </p:sp>
@@ -6296,6 +6344,7 @@
           <a:lstStyle/>
           <a:p>
             <a:pPr algn="ctr"/>
+            <a:endParaRPr/>
           </a:p>
         </p:txBody>
       </p:sp>
@@ -6448,7 +6497,7 @@
 </file>
 
 <file path=ppt/slides/slide12.xml><?xml version="1.0" encoding="utf-8"?>
-<p:sld xmlns:a="http://schemas.openxmlformats.org/drawingml/2006/main" xmlns:p="http://schemas.openxmlformats.org/presentationml/2006/main" xmlns:r="http://schemas.openxmlformats.org/officeDocument/2006/relationships">
+<p:sld xmlns:a="http://schemas.openxmlformats.org/drawingml/2006/main" xmlns:r="http://schemas.openxmlformats.org/officeDocument/2006/relationships" xmlns:p="http://schemas.openxmlformats.org/presentationml/2006/main">
   <p:cSld>
     <p:bg>
       <p:bgPr>
@@ -6464,7 +6513,14 @@
         <p:cNvGrpSpPr/>
         <p:nvPr/>
       </p:nvGrpSpPr>
-      <p:grpSpPr/>
+      <p:grpSpPr>
+        <a:xfrm>
+          <a:off x="0" y="0"/>
+          <a:ext cx="0" cy="0"/>
+          <a:chOff x="0" y="0"/>
+          <a:chExt cx="0" cy="0"/>
+        </a:xfrm>
+      </p:grpSpPr>
       <p:sp>
         <p:nvSpPr>
           <p:cNvPr id="2" name="Rectangle 1"/>
@@ -6505,6 +6561,7 @@
           <a:lstStyle/>
           <a:p>
             <a:pPr algn="ctr"/>
+            <a:endParaRPr/>
           </a:p>
         </p:txBody>
       </p:sp>
@@ -6583,6 +6640,7 @@
           <a:lstStyle/>
           <a:p>
             <a:pPr algn="ctr"/>
+            <a:endParaRPr/>
           </a:p>
         </p:txBody>
       </p:sp>
@@ -6661,6 +6719,7 @@
           <a:lstStyle/>
           <a:p>
             <a:pPr algn="ctr"/>
+            <a:endParaRPr/>
           </a:p>
         </p:txBody>
       </p:sp>
@@ -6778,6 +6837,7 @@
           <a:lstStyle/>
           <a:p>
             <a:pPr algn="ctr"/>
+            <a:endParaRPr/>
           </a:p>
         </p:txBody>
       </p:sp>
@@ -6895,6 +6955,7 @@
           <a:lstStyle/>
           <a:p>
             <a:pPr algn="ctr"/>
+            <a:endParaRPr/>
           </a:p>
         </p:txBody>
       </p:sp>
@@ -7012,6 +7073,7 @@
           <a:lstStyle/>
           <a:p>
             <a:pPr algn="ctr"/>
+            <a:endParaRPr/>
           </a:p>
         </p:txBody>
       </p:sp>
@@ -7318,7 +7380,7 @@
 </file>
 
 <file path=ppt/slides/slide2.xml><?xml version="1.0" encoding="utf-8"?>
-<p:sld xmlns:a="http://schemas.openxmlformats.org/drawingml/2006/main" xmlns:p="http://schemas.openxmlformats.org/presentationml/2006/main" xmlns:r="http://schemas.openxmlformats.org/officeDocument/2006/relationships">
+<p:sld xmlns:a="http://schemas.openxmlformats.org/drawingml/2006/main" xmlns:r="http://schemas.openxmlformats.org/officeDocument/2006/relationships" xmlns:p="http://schemas.openxmlformats.org/presentationml/2006/main">
   <p:cSld>
     <p:bg>
       <p:bgPr>
@@ -7334,7 +7396,14 @@
         <p:cNvGrpSpPr/>
         <p:nvPr/>
       </p:nvGrpSpPr>
-      <p:grpSpPr/>
+      <p:grpSpPr>
+        <a:xfrm>
+          <a:off x="0" y="0"/>
+          <a:ext cx="0" cy="0"/>
+          <a:chOff x="0" y="0"/>
+          <a:chExt cx="0" cy="0"/>
+        </a:xfrm>
+      </p:grpSpPr>
       <p:sp>
         <p:nvSpPr>
           <p:cNvPr id="2" name="Rectangle 1"/>
@@ -7375,6 +7444,7 @@
           <a:lstStyle/>
           <a:p>
             <a:pPr algn="ctr"/>
+            <a:endParaRPr/>
           </a:p>
         </p:txBody>
       </p:sp>
@@ -7453,6 +7523,7 @@
           <a:lstStyle/>
           <a:p>
             <a:pPr algn="ctr"/>
+            <a:endParaRPr/>
           </a:p>
         </p:txBody>
       </p:sp>
@@ -7715,6 +7786,7 @@
           <a:lstStyle/>
           <a:p>
             <a:pPr algn="ctr"/>
+            <a:endParaRPr/>
           </a:p>
         </p:txBody>
       </p:sp>
@@ -7828,6 +7900,7 @@
           <a:lstStyle/>
           <a:p>
             <a:pPr algn="ctr"/>
+            <a:endParaRPr/>
           </a:p>
         </p:txBody>
       </p:sp>
@@ -7941,6 +8014,7 @@
           <a:lstStyle/>
           <a:p>
             <a:pPr algn="ctr"/>
+            <a:endParaRPr/>
           </a:p>
         </p:txBody>
       </p:sp>
@@ -8054,6 +8128,7 @@
           <a:lstStyle/>
           <a:p>
             <a:pPr algn="ctr"/>
+            <a:endParaRPr/>
           </a:p>
         </p:txBody>
       </p:sp>
@@ -8171,7 +8246,7 @@
 </file>
 
 <file path=ppt/slides/slide3.xml><?xml version="1.0" encoding="utf-8"?>
-<p:sld xmlns:a="http://schemas.openxmlformats.org/drawingml/2006/main" xmlns:p="http://schemas.openxmlformats.org/presentationml/2006/main" xmlns:r="http://schemas.openxmlformats.org/officeDocument/2006/relationships">
+<p:sld xmlns:a="http://schemas.openxmlformats.org/drawingml/2006/main" xmlns:r="http://schemas.openxmlformats.org/officeDocument/2006/relationships" xmlns:p="http://schemas.openxmlformats.org/presentationml/2006/main">
   <p:cSld>
     <p:bg>
       <p:bgPr>
@@ -8187,7 +8262,14 @@
         <p:cNvGrpSpPr/>
         <p:nvPr/>
       </p:nvGrpSpPr>
-      <p:grpSpPr/>
+      <p:grpSpPr>
+        <a:xfrm>
+          <a:off x="0" y="0"/>
+          <a:ext cx="0" cy="0"/>
+          <a:chOff x="0" y="0"/>
+          <a:chExt cx="0" cy="0"/>
+        </a:xfrm>
+      </p:grpSpPr>
       <p:sp>
         <p:nvSpPr>
           <p:cNvPr id="2" name="Rectangle 1"/>
@@ -8228,6 +8310,7 @@
           <a:lstStyle/>
           <a:p>
             <a:pPr algn="ctr"/>
+            <a:endParaRPr/>
           </a:p>
         </p:txBody>
       </p:sp>
@@ -8306,6 +8389,7 @@
           <a:lstStyle/>
           <a:p>
             <a:pPr algn="ctr"/>
+            <a:endParaRPr/>
           </a:p>
         </p:txBody>
       </p:sp>
@@ -8349,6 +8433,7 @@
           <a:lstStyle/>
           <a:p>
             <a:pPr algn="ctr"/>
+            <a:endParaRPr/>
           </a:p>
         </p:txBody>
       </p:sp>
@@ -8388,7 +8473,7 @@
           </a:fontRef>
         </p:style>
         <p:txBody>
-          <a:bodyPr rtlCol="0" anchor="ctr" wrap="none"/>
+          <a:bodyPr wrap="none" rtlCol="0" anchor="ctr"/>
           <a:lstStyle/>
           <a:p>
             <a:pPr algn="ctr">
@@ -8514,6 +8599,7 @@
           <a:lstStyle/>
           <a:p>
             <a:pPr algn="ctr"/>
+            <a:endParaRPr/>
           </a:p>
         </p:txBody>
       </p:sp>
@@ -8553,7 +8639,7 @@
           </a:fontRef>
         </p:style>
         <p:txBody>
-          <a:bodyPr rtlCol="0" anchor="ctr" wrap="none"/>
+          <a:bodyPr wrap="none" rtlCol="0" anchor="ctr"/>
           <a:lstStyle/>
           <a:p>
             <a:pPr algn="ctr">
@@ -8679,6 +8765,7 @@
           <a:lstStyle/>
           <a:p>
             <a:pPr algn="ctr"/>
+            <a:endParaRPr/>
           </a:p>
         </p:txBody>
       </p:sp>
@@ -8718,7 +8805,7 @@
           </a:fontRef>
         </p:style>
         <p:txBody>
-          <a:bodyPr rtlCol="0" anchor="ctr" wrap="none"/>
+          <a:bodyPr wrap="none" rtlCol="0" anchor="ctr"/>
           <a:lstStyle/>
           <a:p>
             <a:pPr algn="ctr">
@@ -8844,6 +8931,7 @@
           <a:lstStyle/>
           <a:p>
             <a:pPr algn="ctr"/>
+            <a:endParaRPr/>
           </a:p>
         </p:txBody>
       </p:sp>
@@ -8883,7 +8971,7 @@
           </a:fontRef>
         </p:style>
         <p:txBody>
-          <a:bodyPr rtlCol="0" anchor="ctr" wrap="none"/>
+          <a:bodyPr wrap="none" rtlCol="0" anchor="ctr"/>
           <a:lstStyle/>
           <a:p>
             <a:pPr algn="ctr">
@@ -9009,6 +9097,7 @@
           <a:lstStyle/>
           <a:p>
             <a:pPr algn="ctr"/>
+            <a:endParaRPr/>
           </a:p>
         </p:txBody>
       </p:sp>
@@ -9048,7 +9137,7 @@
           </a:fontRef>
         </p:style>
         <p:txBody>
-          <a:bodyPr rtlCol="0" anchor="ctr" wrap="none"/>
+          <a:bodyPr wrap="none" rtlCol="0" anchor="ctr"/>
           <a:lstStyle/>
           <a:p>
             <a:pPr algn="ctr">
@@ -9174,6 +9263,7 @@
           <a:lstStyle/>
           <a:p>
             <a:pPr algn="ctr"/>
+            <a:endParaRPr/>
           </a:p>
         </p:txBody>
       </p:sp>
@@ -9213,7 +9303,7 @@
           </a:fontRef>
         </p:style>
         <p:txBody>
-          <a:bodyPr rtlCol="0" anchor="ctr" wrap="none"/>
+          <a:bodyPr wrap="none" rtlCol="0" anchor="ctr"/>
           <a:lstStyle/>
           <a:p>
             <a:pPr algn="ctr">
@@ -9343,7 +9433,7 @@
 </file>
 
 <file path=ppt/slides/slide4.xml><?xml version="1.0" encoding="utf-8"?>
-<p:sld xmlns:a="http://schemas.openxmlformats.org/drawingml/2006/main" xmlns:p="http://schemas.openxmlformats.org/presentationml/2006/main" xmlns:r="http://schemas.openxmlformats.org/officeDocument/2006/relationships">
+<p:sld xmlns:a="http://schemas.openxmlformats.org/drawingml/2006/main" xmlns:r="http://schemas.openxmlformats.org/officeDocument/2006/relationships" xmlns:p="http://schemas.openxmlformats.org/presentationml/2006/main">
   <p:cSld>
     <p:bg>
       <p:bgPr>
@@ -9359,7 +9449,14 @@
         <p:cNvGrpSpPr/>
         <p:nvPr/>
       </p:nvGrpSpPr>
-      <p:grpSpPr/>
+      <p:grpSpPr>
+        <a:xfrm>
+          <a:off x="0" y="0"/>
+          <a:ext cx="0" cy="0"/>
+          <a:chOff x="0" y="0"/>
+          <a:chExt cx="0" cy="0"/>
+        </a:xfrm>
+      </p:grpSpPr>
       <p:sp>
         <p:nvSpPr>
           <p:cNvPr id="2" name="Rectangle 1"/>
@@ -9400,6 +9497,7 @@
           <a:lstStyle/>
           <a:p>
             <a:pPr algn="ctr"/>
+            <a:endParaRPr/>
           </a:p>
         </p:txBody>
       </p:sp>
@@ -9478,6 +9576,7 @@
           <a:lstStyle/>
           <a:p>
             <a:pPr algn="ctr"/>
+            <a:endParaRPr/>
           </a:p>
         </p:txBody>
       </p:sp>
@@ -9521,6 +9620,7 @@
           <a:lstStyle/>
           <a:p>
             <a:pPr algn="ctr"/>
+            <a:endParaRPr/>
           </a:p>
         </p:txBody>
       </p:sp>
@@ -9564,6 +9664,7 @@
           <a:lstStyle/>
           <a:p>
             <a:pPr algn="ctr"/>
+            <a:endParaRPr/>
           </a:p>
         </p:txBody>
       </p:sp>
@@ -9677,6 +9778,7 @@
           <a:lstStyle/>
           <a:p>
             <a:pPr algn="ctr"/>
+            <a:endParaRPr/>
           </a:p>
         </p:txBody>
       </p:sp>
@@ -9720,6 +9822,7 @@
           <a:lstStyle/>
           <a:p>
             <a:pPr algn="ctr"/>
+            <a:endParaRPr/>
           </a:p>
         </p:txBody>
       </p:sp>
@@ -9833,6 +9936,7 @@
           <a:lstStyle/>
           <a:p>
             <a:pPr algn="ctr"/>
+            <a:endParaRPr/>
           </a:p>
         </p:txBody>
       </p:sp>
@@ -9876,6 +9980,7 @@
           <a:lstStyle/>
           <a:p>
             <a:pPr algn="ctr"/>
+            <a:endParaRPr/>
           </a:p>
         </p:txBody>
       </p:sp>
@@ -9989,6 +10094,7 @@
           <a:lstStyle/>
           <a:p>
             <a:pPr algn="ctr"/>
+            <a:endParaRPr/>
           </a:p>
         </p:txBody>
       </p:sp>
@@ -10032,6 +10138,7 @@
           <a:lstStyle/>
           <a:p>
             <a:pPr algn="ctr"/>
+            <a:endParaRPr/>
           </a:p>
         </p:txBody>
       </p:sp>
@@ -10145,6 +10252,7 @@
           <a:lstStyle/>
           <a:p>
             <a:pPr algn="ctr"/>
+            <a:endParaRPr/>
           </a:p>
         </p:txBody>
       </p:sp>
@@ -10188,6 +10296,7 @@
           <a:lstStyle/>
           <a:p>
             <a:pPr algn="ctr"/>
+            <a:endParaRPr/>
           </a:p>
         </p:txBody>
       </p:sp>
@@ -10301,6 +10410,7 @@
           <a:lstStyle/>
           <a:p>
             <a:pPr algn="ctr"/>
+            <a:endParaRPr/>
           </a:p>
         </p:txBody>
       </p:sp>
@@ -10344,6 +10454,7 @@
           <a:lstStyle/>
           <a:p>
             <a:pPr algn="ctr"/>
+            <a:endParaRPr/>
           </a:p>
         </p:txBody>
       </p:sp>
@@ -10457,6 +10568,7 @@
           <a:lstStyle/>
           <a:p>
             <a:pPr algn="ctr"/>
+            <a:endParaRPr/>
           </a:p>
         </p:txBody>
       </p:sp>
@@ -10500,6 +10612,7 @@
           <a:lstStyle/>
           <a:p>
             <a:pPr algn="ctr"/>
+            <a:endParaRPr/>
           </a:p>
         </p:txBody>
       </p:sp>
@@ -10613,6 +10726,7 @@
           <a:lstStyle/>
           <a:p>
             <a:pPr algn="ctr"/>
+            <a:endParaRPr/>
           </a:p>
         </p:txBody>
       </p:sp>
@@ -10656,6 +10770,7 @@
           <a:lstStyle/>
           <a:p>
             <a:pPr algn="ctr"/>
+            <a:endParaRPr/>
           </a:p>
         </p:txBody>
       </p:sp>
@@ -10769,6 +10884,7 @@
           <a:lstStyle/>
           <a:p>
             <a:pPr algn="ctr"/>
+            <a:endParaRPr/>
           </a:p>
         </p:txBody>
       </p:sp>
@@ -10812,6 +10928,7 @@
           <a:lstStyle/>
           <a:p>
             <a:pPr algn="ctr"/>
+            <a:endParaRPr/>
           </a:p>
         </p:txBody>
       </p:sp>
@@ -10925,6 +11042,7 @@
           <a:lstStyle/>
           <a:p>
             <a:pPr algn="ctr"/>
+            <a:endParaRPr/>
           </a:p>
         </p:txBody>
       </p:sp>
@@ -10968,6 +11086,7 @@
           <a:lstStyle/>
           <a:p>
             <a:pPr algn="ctr"/>
+            <a:endParaRPr/>
           </a:p>
         </p:txBody>
       </p:sp>
@@ -11085,7 +11204,7 @@
 </file>
 
 <file path=ppt/slides/slide5.xml><?xml version="1.0" encoding="utf-8"?>
-<p:sld xmlns:a="http://schemas.openxmlformats.org/drawingml/2006/main" xmlns:p="http://schemas.openxmlformats.org/presentationml/2006/main" xmlns:r="http://schemas.openxmlformats.org/officeDocument/2006/relationships">
+<p:sld xmlns:a="http://schemas.openxmlformats.org/drawingml/2006/main" xmlns:r="http://schemas.openxmlformats.org/officeDocument/2006/relationships" xmlns:p="http://schemas.openxmlformats.org/presentationml/2006/main">
   <p:cSld>
     <p:bg>
       <p:bgPr>
@@ -11101,7 +11220,14 @@
         <p:cNvGrpSpPr/>
         <p:nvPr/>
       </p:nvGrpSpPr>
-      <p:grpSpPr/>
+      <p:grpSpPr>
+        <a:xfrm>
+          <a:off x="0" y="0"/>
+          <a:ext cx="0" cy="0"/>
+          <a:chOff x="0" y="0"/>
+          <a:chExt cx="0" cy="0"/>
+        </a:xfrm>
+      </p:grpSpPr>
       <p:sp>
         <p:nvSpPr>
           <p:cNvPr id="2" name="Rectangle 1"/>
@@ -11142,6 +11268,7 @@
           <a:lstStyle/>
           <a:p>
             <a:pPr algn="ctr"/>
+            <a:endParaRPr/>
           </a:p>
         </p:txBody>
       </p:sp>
@@ -11220,6 +11347,7 @@
           <a:lstStyle/>
           <a:p>
             <a:pPr algn="ctr"/>
+            <a:endParaRPr/>
           </a:p>
         </p:txBody>
       </p:sp>
@@ -11263,6 +11391,7 @@
           <a:lstStyle/>
           <a:p>
             <a:pPr algn="ctr"/>
+            <a:endParaRPr/>
           </a:p>
         </p:txBody>
       </p:sp>
@@ -11341,6 +11470,7 @@
           <a:lstStyle/>
           <a:p>
             <a:pPr algn="ctr"/>
+            <a:endParaRPr/>
           </a:p>
         </p:txBody>
       </p:sp>
@@ -11522,6 +11652,7 @@
           <a:lstStyle/>
           <a:p>
             <a:pPr algn="ctr"/>
+            <a:endParaRPr/>
           </a:p>
         </p:txBody>
       </p:sp>
@@ -11600,6 +11731,7 @@
           <a:lstStyle/>
           <a:p>
             <a:pPr algn="ctr"/>
+            <a:endParaRPr/>
           </a:p>
         </p:txBody>
       </p:sp>
@@ -11781,6 +11913,7 @@
           <a:lstStyle/>
           <a:p>
             <a:pPr algn="ctr"/>
+            <a:endParaRPr/>
           </a:p>
         </p:txBody>
       </p:sp>
@@ -11859,6 +11992,7 @@
           <a:lstStyle/>
           <a:p>
             <a:pPr algn="ctr"/>
+            <a:endParaRPr/>
           </a:p>
         </p:txBody>
       </p:sp>
@@ -12040,6 +12174,7 @@
           <a:lstStyle/>
           <a:p>
             <a:pPr algn="ctr"/>
+            <a:endParaRPr/>
           </a:p>
         </p:txBody>
       </p:sp>
@@ -12083,6 +12218,7 @@
           <a:lstStyle/>
           <a:p>
             <a:pPr algn="ctr"/>
+            <a:endParaRPr/>
           </a:p>
         </p:txBody>
       </p:sp>
@@ -12161,6 +12297,7 @@
           <a:lstStyle/>
           <a:p>
             <a:pPr algn="ctr"/>
+            <a:endParaRPr/>
           </a:p>
         </p:txBody>
       </p:sp>
@@ -12278,6 +12415,7 @@
           <a:lstStyle/>
           <a:p>
             <a:pPr algn="ctr"/>
+            <a:endParaRPr/>
           </a:p>
         </p:txBody>
       </p:sp>
@@ -12395,6 +12533,7 @@
           <a:lstStyle/>
           <a:p>
             <a:pPr algn="ctr"/>
+            <a:endParaRPr/>
           </a:p>
         </p:txBody>
       </p:sp>
@@ -12512,6 +12651,7 @@
           <a:lstStyle/>
           <a:p>
             <a:pPr algn="ctr"/>
+            <a:endParaRPr/>
           </a:p>
         </p:txBody>
       </p:sp>
@@ -12633,7 +12773,7 @@
 </file>
 
 <file path=ppt/slides/slide6.xml><?xml version="1.0" encoding="utf-8"?>
-<p:sld xmlns:a="http://schemas.openxmlformats.org/drawingml/2006/main" xmlns:p="http://schemas.openxmlformats.org/presentationml/2006/main" xmlns:r="http://schemas.openxmlformats.org/officeDocument/2006/relationships">
+<p:sld xmlns:a="http://schemas.openxmlformats.org/drawingml/2006/main" xmlns:r="http://schemas.openxmlformats.org/officeDocument/2006/relationships" xmlns:p="http://schemas.openxmlformats.org/presentationml/2006/main">
   <p:cSld>
     <p:bg>
       <p:bgPr>
@@ -12649,7 +12789,14 @@
         <p:cNvGrpSpPr/>
         <p:nvPr/>
       </p:nvGrpSpPr>
-      <p:grpSpPr/>
+      <p:grpSpPr>
+        <a:xfrm>
+          <a:off x="0" y="0"/>
+          <a:ext cx="0" cy="0"/>
+          <a:chOff x="0" y="0"/>
+          <a:chExt cx="0" cy="0"/>
+        </a:xfrm>
+      </p:grpSpPr>
       <p:sp>
         <p:nvSpPr>
           <p:cNvPr id="2" name="Rectangle 1"/>
@@ -12690,6 +12837,7 @@
           <a:lstStyle/>
           <a:p>
             <a:pPr algn="ctr"/>
+            <a:endParaRPr/>
           </a:p>
         </p:txBody>
       </p:sp>
@@ -12768,6 +12916,7 @@
           <a:lstStyle/>
           <a:p>
             <a:pPr algn="ctr"/>
+            <a:endParaRPr/>
           </a:p>
         </p:txBody>
       </p:sp>
@@ -12846,6 +12995,7 @@
           <a:lstStyle/>
           <a:p>
             <a:pPr algn="ctr"/>
+            <a:endParaRPr/>
           </a:p>
         </p:txBody>
       </p:sp>
@@ -12889,6 +13039,7 @@
           <a:lstStyle/>
           <a:p>
             <a:pPr algn="ctr"/>
+            <a:endParaRPr/>
           </a:p>
         </p:txBody>
       </p:sp>
@@ -13002,6 +13153,7 @@
           <a:lstStyle/>
           <a:p>
             <a:pPr algn="ctr"/>
+            <a:endParaRPr/>
           </a:p>
         </p:txBody>
       </p:sp>
@@ -13115,6 +13267,7 @@
           <a:lstStyle/>
           <a:p>
             <a:pPr algn="ctr"/>
+            <a:endParaRPr/>
           </a:p>
         </p:txBody>
       </p:sp>
@@ -13228,6 +13381,7 @@
           <a:lstStyle/>
           <a:p>
             <a:pPr algn="ctr"/>
+            <a:endParaRPr/>
           </a:p>
         </p:txBody>
       </p:sp>
@@ -13341,6 +13495,7 @@
           <a:lstStyle/>
           <a:p>
             <a:pPr algn="ctr"/>
+            <a:endParaRPr/>
           </a:p>
         </p:txBody>
       </p:sp>
@@ -13454,6 +13609,7 @@
           <a:lstStyle/>
           <a:p>
             <a:pPr algn="ctr"/>
+            <a:endParaRPr/>
           </a:p>
         </p:txBody>
       </p:sp>
@@ -13567,6 +13723,7 @@
           <a:lstStyle/>
           <a:p>
             <a:pPr algn="ctr"/>
+            <a:endParaRPr/>
           </a:p>
         </p:txBody>
       </p:sp>
@@ -13715,6 +13872,7 @@
           <a:lstStyle/>
           <a:p>
             <a:pPr algn="ctr"/>
+            <a:endParaRPr/>
           </a:p>
         </p:txBody>
       </p:sp>
@@ -13758,6 +13916,7 @@
           <a:lstStyle/>
           <a:p>
             <a:pPr algn="ctr"/>
+            <a:endParaRPr/>
           </a:p>
         </p:txBody>
       </p:sp>
@@ -13871,6 +14030,7 @@
           <a:lstStyle/>
           <a:p>
             <a:pPr algn="ctr"/>
+            <a:endParaRPr/>
           </a:p>
         </p:txBody>
       </p:sp>
@@ -13984,6 +14144,7 @@
           <a:lstStyle/>
           <a:p>
             <a:pPr algn="ctr"/>
+            <a:endParaRPr/>
           </a:p>
         </p:txBody>
       </p:sp>
@@ -14097,6 +14258,7 @@
           <a:lstStyle/>
           <a:p>
             <a:pPr algn="ctr"/>
+            <a:endParaRPr/>
           </a:p>
         </p:txBody>
       </p:sp>
@@ -14210,6 +14372,7 @@
           <a:lstStyle/>
           <a:p>
             <a:pPr algn="ctr"/>
+            <a:endParaRPr/>
           </a:p>
         </p:txBody>
       </p:sp>
@@ -14323,6 +14486,7 @@
           <a:lstStyle/>
           <a:p>
             <a:pPr algn="ctr"/>
+            <a:endParaRPr/>
           </a:p>
         </p:txBody>
       </p:sp>
@@ -14436,6 +14600,7 @@
           <a:lstStyle/>
           <a:p>
             <a:pPr algn="ctr"/>
+            <a:endParaRPr/>
           </a:p>
         </p:txBody>
       </p:sp>
@@ -14584,6 +14749,7 @@
           <a:lstStyle/>
           <a:p>
             <a:pPr algn="ctr"/>
+            <a:endParaRPr/>
           </a:p>
         </p:txBody>
       </p:sp>
@@ -14627,6 +14793,7 @@
           <a:lstStyle/>
           <a:p>
             <a:pPr algn="ctr"/>
+            <a:endParaRPr/>
           </a:p>
         </p:txBody>
       </p:sp>
@@ -14740,6 +14907,7 @@
           <a:lstStyle/>
           <a:p>
             <a:pPr algn="ctr"/>
+            <a:endParaRPr/>
           </a:p>
         </p:txBody>
       </p:sp>
@@ -14853,6 +15021,7 @@
           <a:lstStyle/>
           <a:p>
             <a:pPr algn="ctr"/>
+            <a:endParaRPr/>
           </a:p>
         </p:txBody>
       </p:sp>
@@ -14966,6 +15135,7 @@
           <a:lstStyle/>
           <a:p>
             <a:pPr algn="ctr"/>
+            <a:endParaRPr/>
           </a:p>
         </p:txBody>
       </p:sp>
@@ -15079,6 +15249,7 @@
           <a:lstStyle/>
           <a:p>
             <a:pPr algn="ctr"/>
+            <a:endParaRPr/>
           </a:p>
         </p:txBody>
       </p:sp>
@@ -15192,6 +15363,7 @@
           <a:lstStyle/>
           <a:p>
             <a:pPr algn="ctr"/>
+            <a:endParaRPr/>
           </a:p>
         </p:txBody>
       </p:sp>
@@ -15305,6 +15477,7 @@
           <a:lstStyle/>
           <a:p>
             <a:pPr algn="ctr"/>
+            <a:endParaRPr/>
           </a:p>
         </p:txBody>
       </p:sp>
@@ -15422,7 +15595,7 @@
 </file>
 
 <file path=ppt/slides/slide7.xml><?xml version="1.0" encoding="utf-8"?>
-<p:sld xmlns:a="http://schemas.openxmlformats.org/drawingml/2006/main" xmlns:p="http://schemas.openxmlformats.org/presentationml/2006/main" xmlns:r="http://schemas.openxmlformats.org/officeDocument/2006/relationships">
+<p:sld xmlns:a="http://schemas.openxmlformats.org/drawingml/2006/main" xmlns:r="http://schemas.openxmlformats.org/officeDocument/2006/relationships" xmlns:p="http://schemas.openxmlformats.org/presentationml/2006/main">
   <p:cSld>
     <p:bg>
       <p:bgPr>
@@ -15438,7 +15611,14 @@
         <p:cNvGrpSpPr/>
         <p:nvPr/>
       </p:nvGrpSpPr>
-      <p:grpSpPr/>
+      <p:grpSpPr>
+        <a:xfrm>
+          <a:off x="0" y="0"/>
+          <a:ext cx="0" cy="0"/>
+          <a:chOff x="0" y="0"/>
+          <a:chExt cx="0" cy="0"/>
+        </a:xfrm>
+      </p:grpSpPr>
       <p:sp>
         <p:nvSpPr>
           <p:cNvPr id="2" name="Rectangle 1"/>
@@ -15479,6 +15659,7 @@
           <a:lstStyle/>
           <a:p>
             <a:pPr algn="ctr"/>
+            <a:endParaRPr/>
           </a:p>
         </p:txBody>
       </p:sp>
@@ -15557,6 +15738,7 @@
           <a:lstStyle/>
           <a:p>
             <a:pPr algn="ctr"/>
+            <a:endParaRPr/>
           </a:p>
         </p:txBody>
       </p:sp>
@@ -15600,6 +15782,7 @@
           <a:lstStyle/>
           <a:p>
             <a:pPr algn="ctr"/>
+            <a:endParaRPr/>
           </a:p>
         </p:txBody>
       </p:sp>
@@ -15773,6 +15956,7 @@
           <a:lstStyle/>
           <a:p>
             <a:pPr algn="ctr"/>
+            <a:endParaRPr/>
           </a:p>
         </p:txBody>
       </p:sp>
@@ -15816,6 +16000,7 @@
           <a:lstStyle/>
           <a:p>
             <a:pPr algn="ctr"/>
+            <a:endParaRPr/>
           </a:p>
         </p:txBody>
       </p:sp>
@@ -15989,6 +16174,7 @@
           <a:lstStyle/>
           <a:p>
             <a:pPr algn="ctr"/>
+            <a:endParaRPr/>
           </a:p>
         </p:txBody>
       </p:sp>
@@ -16032,6 +16218,7 @@
           <a:lstStyle/>
           <a:p>
             <a:pPr algn="ctr"/>
+            <a:endParaRPr/>
           </a:p>
         </p:txBody>
       </p:sp>
@@ -16205,6 +16392,7 @@
           <a:lstStyle/>
           <a:p>
             <a:pPr algn="ctr"/>
+            <a:endParaRPr/>
           </a:p>
         </p:txBody>
       </p:sp>
@@ -16248,6 +16436,7 @@
           <a:lstStyle/>
           <a:p>
             <a:pPr algn="ctr"/>
+            <a:endParaRPr/>
           </a:p>
         </p:txBody>
       </p:sp>
@@ -16421,6 +16610,7 @@
           <a:lstStyle/>
           <a:p>
             <a:pPr algn="ctr"/>
+            <a:endParaRPr/>
           </a:p>
         </p:txBody>
       </p:sp>
@@ -16464,6 +16654,7 @@
           <a:lstStyle/>
           <a:p>
             <a:pPr algn="ctr"/>
+            <a:endParaRPr/>
           </a:p>
         </p:txBody>
       </p:sp>
@@ -16637,6 +16828,7 @@
           <a:lstStyle/>
           <a:p>
             <a:pPr algn="ctr"/>
+            <a:endParaRPr/>
           </a:p>
         </p:txBody>
       </p:sp>
@@ -16680,6 +16872,7 @@
           <a:lstStyle/>
           <a:p>
             <a:pPr algn="ctr"/>
+            <a:endParaRPr/>
           </a:p>
         </p:txBody>
       </p:sp>
@@ -16888,6 +17081,7 @@
           <a:lstStyle/>
           <a:p>
             <a:pPr algn="ctr"/>
+            <a:endParaRPr/>
           </a:p>
         </p:txBody>
       </p:sp>
@@ -17005,6 +17199,7 @@
           <a:lstStyle/>
           <a:p>
             <a:pPr algn="ctr"/>
+            <a:endParaRPr/>
           </a:p>
         </p:txBody>
       </p:sp>
@@ -17122,6 +17317,7 @@
           <a:lstStyle/>
           <a:p>
             <a:pPr algn="ctr"/>
+            <a:endParaRPr/>
           </a:p>
         </p:txBody>
       </p:sp>
@@ -17239,6 +17435,7 @@
           <a:lstStyle/>
           <a:p>
             <a:pPr algn="ctr"/>
+            <a:endParaRPr/>
           </a:p>
         </p:txBody>
       </p:sp>
@@ -17360,7 +17557,7 @@
 </file>
 
 <file path=ppt/slides/slide8.xml><?xml version="1.0" encoding="utf-8"?>
-<p:sld xmlns:a="http://schemas.openxmlformats.org/drawingml/2006/main" xmlns:p="http://schemas.openxmlformats.org/presentationml/2006/main" xmlns:r="http://schemas.openxmlformats.org/officeDocument/2006/relationships">
+<p:sld xmlns:a="http://schemas.openxmlformats.org/drawingml/2006/main" xmlns:r="http://schemas.openxmlformats.org/officeDocument/2006/relationships" xmlns:p="http://schemas.openxmlformats.org/presentationml/2006/main">
   <p:cSld>
     <p:bg>
       <p:bgPr>
@@ -17376,7 +17573,14 @@
         <p:cNvGrpSpPr/>
         <p:nvPr/>
       </p:nvGrpSpPr>
-      <p:grpSpPr/>
+      <p:grpSpPr>
+        <a:xfrm>
+          <a:off x="0" y="0"/>
+          <a:ext cx="0" cy="0"/>
+          <a:chOff x="0" y="0"/>
+          <a:chExt cx="0" cy="0"/>
+        </a:xfrm>
+      </p:grpSpPr>
       <p:sp>
         <p:nvSpPr>
           <p:cNvPr id="2" name="Rectangle 1"/>
@@ -17417,6 +17621,7 @@
           <a:lstStyle/>
           <a:p>
             <a:pPr algn="ctr"/>
+            <a:endParaRPr/>
           </a:p>
         </p:txBody>
       </p:sp>
@@ -17495,6 +17700,7 @@
           <a:lstStyle/>
           <a:p>
             <a:pPr algn="ctr"/>
+            <a:endParaRPr/>
           </a:p>
         </p:txBody>
       </p:sp>
@@ -18022,6 +18228,7 @@
           <a:lstStyle/>
           <a:p>
             <a:pPr algn="ctr"/>
+            <a:endParaRPr/>
           </a:p>
         </p:txBody>
       </p:sp>
@@ -18104,7 +18311,7 @@
 </file>
 
 <file path=ppt/slides/slide9.xml><?xml version="1.0" encoding="utf-8"?>
-<p:sld xmlns:a="http://schemas.openxmlformats.org/drawingml/2006/main" xmlns:p="http://schemas.openxmlformats.org/presentationml/2006/main" xmlns:r="http://schemas.openxmlformats.org/officeDocument/2006/relationships">
+<p:sld xmlns:a="http://schemas.openxmlformats.org/drawingml/2006/main" xmlns:r="http://schemas.openxmlformats.org/officeDocument/2006/relationships" xmlns:p="http://schemas.openxmlformats.org/presentationml/2006/main">
   <p:cSld>
     <p:bg>
       <p:bgPr>
@@ -18120,7 +18327,14 @@
         <p:cNvGrpSpPr/>
         <p:nvPr/>
       </p:nvGrpSpPr>
-      <p:grpSpPr/>
+      <p:grpSpPr>
+        <a:xfrm>
+          <a:off x="0" y="0"/>
+          <a:ext cx="0" cy="0"/>
+          <a:chOff x="0" y="0"/>
+          <a:chExt cx="0" cy="0"/>
+        </a:xfrm>
+      </p:grpSpPr>
       <p:sp>
         <p:nvSpPr>
           <p:cNvPr id="2" name="Rectangle 1"/>
@@ -18161,6 +18375,7 @@
           <a:lstStyle/>
           <a:p>
             <a:pPr algn="ctr"/>
+            <a:endParaRPr/>
           </a:p>
         </p:txBody>
       </p:sp>
@@ -18239,6 +18454,7 @@
           <a:lstStyle/>
           <a:p>
             <a:pPr algn="ctr"/>
+            <a:endParaRPr/>
           </a:p>
         </p:txBody>
       </p:sp>
@@ -18282,6 +18498,7 @@
           <a:lstStyle/>
           <a:p>
             <a:pPr algn="ctr"/>
+            <a:endParaRPr/>
           </a:p>
         </p:txBody>
       </p:sp>
@@ -18360,6 +18577,7 @@
           <a:lstStyle/>
           <a:p>
             <a:pPr algn="ctr"/>
+            <a:endParaRPr/>
           </a:p>
         </p:txBody>
       </p:sp>
@@ -18541,6 +18759,7 @@
           <a:lstStyle/>
           <a:p>
             <a:pPr algn="ctr"/>
+            <a:endParaRPr/>
           </a:p>
         </p:txBody>
       </p:sp>
@@ -18619,6 +18838,7 @@
           <a:lstStyle/>
           <a:p>
             <a:pPr algn="ctr"/>
+            <a:endParaRPr/>
           </a:p>
         </p:txBody>
       </p:sp>
@@ -18823,6 +19043,7 @@
           <a:lstStyle/>
           <a:p>
             <a:pPr algn="ctr"/>
+            <a:endParaRPr/>
           </a:p>
         </p:txBody>
       </p:sp>
@@ -18901,6 +19122,7 @@
           <a:lstStyle/>
           <a:p>
             <a:pPr algn="ctr"/>
+            <a:endParaRPr/>
           </a:p>
         </p:txBody>
       </p:sp>
@@ -19128,6 +19350,7 @@
           <a:lstStyle/>
           <a:p>
             <a:pPr algn="ctr"/>
+            <a:endParaRPr/>
           </a:p>
         </p:txBody>
       </p:sp>
@@ -19206,6 +19429,7 @@
           <a:lstStyle/>
           <a:p>
             <a:pPr algn="ctr"/>
+            <a:endParaRPr/>
           </a:p>
         </p:txBody>
       </p:sp>

</xml_diff>